<commit_message>
Added updated diploma thesis presentation
</commit_message>
<xml_diff>
--- a/Chapters/Diploma_thesis_presentation.pptx
+++ b/Chapters/Diploma_thesis_presentation.pptx
@@ -5,28 +5,33 @@
     <p:sldMasterId id="2147483648" r:id="rId1"/>
   </p:sldMasterIdLst>
   <p:notesMasterIdLst>
-    <p:notesMasterId r:id="rId7"/>
+    <p:notesMasterId r:id="rId8"/>
   </p:notesMasterIdLst>
   <p:handoutMasterIdLst>
-    <p:handoutMasterId r:id="rId8"/>
+    <p:handoutMasterId r:id="rId9"/>
   </p:handoutMasterIdLst>
   <p:sldIdLst>
     <p:sldId id="257" r:id="rId2"/>
     <p:sldId id="3744" r:id="rId3"/>
     <p:sldId id="3743" r:id="rId4"/>
     <p:sldId id="268" r:id="rId5"/>
-    <p:sldId id="3745" r:id="rId6"/>
+    <p:sldId id="3747" r:id="rId6"/>
+    <p:sldId id="3746" r:id="rId7"/>
   </p:sldIdLst>
   <p:sldSz cx="12192000" cy="6858000"/>
   <p:notesSz cx="6858000" cy="9144000"/>
   <p:embeddedFontLst>
     <p:embeddedFont>
+      <p:font typeface="Algerian" panose="04020705040A02060702" pitchFamily="82" charset="0"/>
+      <p:regular r:id="rId10"/>
+    </p:embeddedFont>
+    <p:embeddedFont>
       <p:font typeface="Cambria Math" panose="02040503050406030204" pitchFamily="18" charset="0"/>
-      <p:regular r:id="rId9"/>
+      <p:regular r:id="rId11"/>
     </p:embeddedFont>
   </p:embeddedFontLst>
   <p:custDataLst>
-    <p:tags r:id="rId10"/>
+    <p:tags r:id="rId12"/>
   </p:custDataLst>
   <p:defaultTextStyle>
     <a:defPPr>
@@ -132,7 +137,8 @@
             <p14:sldId id="3744"/>
             <p14:sldId id="3743"/>
             <p14:sldId id="268"/>
-            <p14:sldId id="3745"/>
+            <p14:sldId id="3747"/>
+            <p14:sldId id="3746"/>
           </p14:sldIdLst>
         </p14:section>
         <p14:section name="Standardabschnitt" id="{DFA7A10C-E1EB-4972-AB36-D2ACD314A82C}">
@@ -288,7 +294,7 @@
               <a:rPr lang="de-AT" smtClean="0">
                 <a:latin typeface="Arial" panose="020B0604020202020204" pitchFamily="34" charset="0"/>
               </a:rPr>
-              <a:t>04.11.2025</a:t>
+              <a:t>05.01.2026</a:t>
             </a:fld>
             <a:endParaRPr lang="de-AT" dirty="0">
               <a:latin typeface="Arial" panose="020B0604020202020204" pitchFamily="34" charset="0"/>
@@ -378,7 +384,7 @@
               <a:rPr lang="de-AT" smtClean="0">
                 <a:latin typeface="Arial" panose="020B0604020202020204" pitchFamily="34" charset="0"/>
               </a:rPr>
-              <a:t>‹Nr.›</a:t>
+              <a:t>‹#›</a:t>
             </a:fld>
             <a:endParaRPr lang="de-AT" dirty="0">
               <a:latin typeface="Arial" panose="020B0604020202020204" pitchFamily="34" charset="0"/>
@@ -490,7 +496,7 @@
             <a:fld id="{C116C0E1-FA71-4E92-9BA0-377972D4F09A}" type="datetimeFigureOut">
               <a:rPr lang="de-AT" smtClean="0"/>
               <a:pPr/>
-              <a:t>04.11.2025</a:t>
+              <a:t>05.01.2026</a:t>
             </a:fld>
             <a:endParaRPr lang="de-AT" dirty="0"/>
           </a:p>
@@ -665,7 +671,7 @@
             <a:fld id="{DD8BEB3B-C5EA-45F3-97F0-E17E2A187F46}" type="slidenum">
               <a:rPr lang="de-AT" smtClean="0"/>
               <a:pPr/>
-              <a:t>‹Nr.›</a:t>
+              <a:t>‹#›</a:t>
             </a:fld>
             <a:endParaRPr lang="de-AT" dirty="0"/>
           </a:p>
@@ -1194,123 +1200,6 @@
 </p:notes>
 </file>
 
-<file path=ppt/notesSlides/notesSlide5.xml><?xml version="1.0" encoding="utf-8"?>
-<p:notes xmlns:a="http://schemas.openxmlformats.org/drawingml/2006/main" xmlns:r="http://schemas.openxmlformats.org/officeDocument/2006/relationships" xmlns:p="http://schemas.openxmlformats.org/presentationml/2006/main">
-  <p:cSld>
-    <p:spTree>
-      <p:nvGrpSpPr>
-        <p:cNvPr id="1" name="">
-          <a:extLst>
-            <a:ext uri="{FF2B5EF4-FFF2-40B4-BE49-F238E27FC236}">
-              <a16:creationId xmlns:a16="http://schemas.microsoft.com/office/drawing/2014/main" id="{9F94C309-2537-CD28-A48E-9849E435472C}"/>
-            </a:ext>
-          </a:extLst>
-        </p:cNvPr>
-        <p:cNvGrpSpPr/>
-        <p:nvPr/>
-      </p:nvGrpSpPr>
-      <p:grpSpPr>
-        <a:xfrm>
-          <a:off x="0" y="0"/>
-          <a:ext cx="0" cy="0"/>
-          <a:chOff x="0" y="0"/>
-          <a:chExt cx="0" cy="0"/>
-        </a:xfrm>
-      </p:grpSpPr>
-      <p:sp>
-        <p:nvSpPr>
-          <p:cNvPr id="2" name="Folienbildplatzhalter 1">
-            <a:extLst>
-              <a:ext uri="{FF2B5EF4-FFF2-40B4-BE49-F238E27FC236}">
-                <a16:creationId xmlns:a16="http://schemas.microsoft.com/office/drawing/2014/main" id="{17B91394-C475-2A1D-08E0-CB36D050B927}"/>
-              </a:ext>
-            </a:extLst>
-          </p:cNvPr>
-          <p:cNvSpPr>
-            <a:spLocks noGrp="1" noRot="1" noChangeAspect="1"/>
-          </p:cNvSpPr>
-          <p:nvPr>
-            <p:ph type="sldImg"/>
-            <p:custDataLst>
-              <p:tags r:id="rId1"/>
-            </p:custDataLst>
-          </p:nvPr>
-        </p:nvSpPr>
-        <p:spPr/>
-      </p:sp>
-      <p:sp>
-        <p:nvSpPr>
-          <p:cNvPr id="3" name="Notizenplatzhalter 2">
-            <a:extLst>
-              <a:ext uri="{FF2B5EF4-FFF2-40B4-BE49-F238E27FC236}">
-                <a16:creationId xmlns:a16="http://schemas.microsoft.com/office/drawing/2014/main" id="{B7F6B3EE-3153-3F14-43A8-AF1D0491BD88}"/>
-              </a:ext>
-            </a:extLst>
-          </p:cNvPr>
-          <p:cNvSpPr>
-            <a:spLocks noGrp="1"/>
-          </p:cNvSpPr>
-          <p:nvPr>
-            <p:ph type="body" idx="1"/>
-            <p:custDataLst>
-              <p:tags r:id="rId2"/>
-            </p:custDataLst>
-          </p:nvPr>
-        </p:nvSpPr>
-        <p:spPr/>
-        <p:txBody>
-          <a:bodyPr/>
-          <a:lstStyle/>
-          <a:p>
-            <a:endParaRPr lang="de-AT" dirty="0"/>
-          </a:p>
-        </p:txBody>
-      </p:sp>
-      <p:sp>
-        <p:nvSpPr>
-          <p:cNvPr id="4" name="Foliennummernplatzhalter 3">
-            <a:extLst>
-              <a:ext uri="{FF2B5EF4-FFF2-40B4-BE49-F238E27FC236}">
-                <a16:creationId xmlns:a16="http://schemas.microsoft.com/office/drawing/2014/main" id="{1ECECF4A-C419-513B-8BBD-0118ECE2F96E}"/>
-              </a:ext>
-            </a:extLst>
-          </p:cNvPr>
-          <p:cNvSpPr>
-            <a:spLocks noGrp="1"/>
-          </p:cNvSpPr>
-          <p:nvPr>
-            <p:ph type="sldNum" sz="quarter" idx="5"/>
-            <p:custDataLst>
-              <p:tags r:id="rId3"/>
-            </p:custDataLst>
-          </p:nvPr>
-        </p:nvSpPr>
-        <p:spPr/>
-        <p:txBody>
-          <a:bodyPr/>
-          <a:lstStyle/>
-          <a:p>
-            <a:fld id="{DD8BEB3B-C5EA-45F3-97F0-E17E2A187F46}" type="slidenum">
-              <a:rPr lang="de-AT" smtClean="0"/>
-              <a:t>5</a:t>
-            </a:fld>
-            <a:endParaRPr lang="de-AT" dirty="0"/>
-          </a:p>
-        </p:txBody>
-      </p:sp>
-    </p:spTree>
-    <p:extLst>
-      <p:ext uri="{BB962C8B-B14F-4D97-AF65-F5344CB8AC3E}">
-        <p14:creationId xmlns:p14="http://schemas.microsoft.com/office/powerpoint/2010/main" val="690174248"/>
-      </p:ext>
-    </p:extLst>
-  </p:cSld>
-  <p:clrMapOvr>
-    <a:masterClrMapping/>
-  </p:clrMapOvr>
-</p:notes>
-</file>
-
 <file path=ppt/slideLayouts/slideLayout1.xml><?xml version="1.0" encoding="utf-8"?>
 <p:sldLayout xmlns:a="http://schemas.openxmlformats.org/drawingml/2006/main" xmlns:r="http://schemas.openxmlformats.org/officeDocument/2006/relationships" xmlns:p="http://schemas.openxmlformats.org/presentationml/2006/main" preserve="1" userDrawn="1">
   <p:cSld name="Titelfolie">
@@ -1639,7 +1528,7 @@
             <a:fld id="{418F7AD7-DC47-44A0-A9D7-F1C17BFD6F09}" type="slidenum">
               <a:rPr lang="de-AT" smtClean="0"/>
               <a:pPr/>
-              <a:t>‹Nr.›</a:t>
+              <a:t>‹#›</a:t>
             </a:fld>
             <a:endParaRPr lang="de-AT" dirty="0"/>
           </a:p>
@@ -2428,7 +2317,7 @@
             <a:fld id="{418F7AD7-DC47-44A0-A9D7-F1C17BFD6F09}" type="slidenum">
               <a:rPr lang="de-AT" smtClean="0"/>
               <a:pPr/>
-              <a:t>‹Nr.›</a:t>
+              <a:t>‹#›</a:t>
             </a:fld>
             <a:endParaRPr lang="de-AT" dirty="0"/>
           </a:p>
@@ -2793,7 +2682,7 @@
             <a:fld id="{418F7AD7-DC47-44A0-A9D7-F1C17BFD6F09}" type="slidenum">
               <a:rPr lang="de-AT" smtClean="0"/>
               <a:pPr/>
-              <a:t>‹Nr.›</a:t>
+              <a:t>‹#›</a:t>
             </a:fld>
             <a:endParaRPr lang="de-AT" dirty="0"/>
           </a:p>
@@ -3057,7 +2946,7 @@
             <a:fld id="{418F7AD7-DC47-44A0-A9D7-F1C17BFD6F09}" type="slidenum">
               <a:rPr lang="de-AT" smtClean="0"/>
               <a:pPr/>
-              <a:t>‹Nr.›</a:t>
+              <a:t>‹#›</a:t>
             </a:fld>
             <a:endParaRPr lang="de-AT" dirty="0"/>
           </a:p>
@@ -3422,7 +3311,7 @@
             <a:fld id="{418F7AD7-DC47-44A0-A9D7-F1C17BFD6F09}" type="slidenum">
               <a:rPr lang="de-AT" smtClean="0"/>
               <a:pPr/>
-              <a:t>‹Nr.›</a:t>
+              <a:t>‹#›</a:t>
             </a:fld>
             <a:endParaRPr lang="de-AT" dirty="0"/>
           </a:p>
@@ -3674,7 +3563,7 @@
             <a:fld id="{418F7AD7-DC47-44A0-A9D7-F1C17BFD6F09}" type="slidenum">
               <a:rPr lang="de-AT" smtClean="0"/>
               <a:pPr/>
-              <a:t>‹Nr.›</a:t>
+              <a:t>‹#›</a:t>
             </a:fld>
             <a:endParaRPr lang="de-AT" dirty="0"/>
           </a:p>
@@ -3887,7 +3776,7 @@
             <a:fld id="{418F7AD7-DC47-44A0-A9D7-F1C17BFD6F09}" type="slidenum">
               <a:rPr lang="de-AT" smtClean="0"/>
               <a:pPr/>
-              <a:t>‹Nr.›</a:t>
+              <a:t>‹#›</a:t>
             </a:fld>
             <a:endParaRPr lang="de-AT" dirty="0"/>
           </a:p>
@@ -4139,7 +4028,7 @@
             <a:fld id="{418F7AD7-DC47-44A0-A9D7-F1C17BFD6F09}" type="slidenum">
               <a:rPr lang="de-AT" smtClean="0"/>
               <a:pPr/>
-              <a:t>‹Nr.›</a:t>
+              <a:t>‹#›</a:t>
             </a:fld>
             <a:endParaRPr lang="de-AT" dirty="0"/>
           </a:p>
@@ -5416,7 +5305,7 @@
             <a:fld id="{418F7AD7-DC47-44A0-A9D7-F1C17BFD6F09}" type="slidenum">
               <a:rPr lang="de-AT" smtClean="0"/>
               <a:pPr/>
-              <a:t>‹Nr.›</a:t>
+              <a:t>‹#›</a:t>
             </a:fld>
             <a:endParaRPr lang="de-AT" dirty="0"/>
           </a:p>
@@ -5748,7 +5637,7 @@
             <a:fld id="{418F7AD7-DC47-44A0-A9D7-F1C17BFD6F09}" type="slidenum">
               <a:rPr lang="de-AT" smtClean="0"/>
               <a:pPr/>
-              <a:t>‹Nr.›</a:t>
+              <a:t>‹#›</a:t>
             </a:fld>
             <a:endParaRPr lang="de-AT" dirty="0"/>
           </a:p>
@@ -6077,7 +5966,7 @@
             <a:fld id="{418F7AD7-DC47-44A0-A9D7-F1C17BFD6F09}" type="slidenum">
               <a:rPr lang="de-AT" smtClean="0"/>
               <a:pPr/>
-              <a:t>‹Nr.›</a:t>
+              <a:t>‹#›</a:t>
             </a:fld>
             <a:endParaRPr lang="de-AT" dirty="0"/>
           </a:p>
@@ -6574,7 +6463,7 @@
             <a:fld id="{418F7AD7-DC47-44A0-A9D7-F1C17BFD6F09}" type="slidenum">
               <a:rPr lang="de-AT" smtClean="0"/>
               <a:pPr/>
-              <a:t>‹Nr.›</a:t>
+              <a:t>‹#›</a:t>
             </a:fld>
             <a:endParaRPr lang="de-AT" dirty="0"/>
           </a:p>
@@ -7059,7 +6948,7 @@
             <a:fld id="{418F7AD7-DC47-44A0-A9D7-F1C17BFD6F09}" type="slidenum">
               <a:rPr lang="de-AT" smtClean="0"/>
               <a:pPr/>
-              <a:t>‹Nr.›</a:t>
+              <a:t>‹#›</a:t>
             </a:fld>
             <a:endParaRPr lang="de-AT" dirty="0"/>
           </a:p>
@@ -7594,7 +7483,7 @@
             <a:fld id="{418F7AD7-DC47-44A0-A9D7-F1C17BFD6F09}" type="slidenum">
               <a:rPr lang="de-AT" smtClean="0"/>
               <a:pPr/>
-              <a:t>‹Nr.›</a:t>
+              <a:t>‹#›</a:t>
             </a:fld>
             <a:endParaRPr lang="de-AT" dirty="0"/>
           </a:p>
@@ -8142,7 +8031,7 @@
             <a:fld id="{418F7AD7-DC47-44A0-A9D7-F1C17BFD6F09}" type="slidenum">
               <a:rPr lang="de-AT" smtClean="0"/>
               <a:pPr/>
-              <a:t>‹Nr.›</a:t>
+              <a:t>‹#›</a:t>
             </a:fld>
             <a:endParaRPr lang="de-AT" dirty="0"/>
           </a:p>
@@ -8783,7 +8672,7 @@
             <a:fld id="{418F7AD7-DC47-44A0-A9D7-F1C17BFD6F09}" type="slidenum">
               <a:rPr lang="de-AT" smtClean="0"/>
               <a:pPr/>
-              <a:t>‹Nr.›</a:t>
+              <a:t>‹#›</a:t>
             </a:fld>
             <a:endParaRPr lang="de-AT" dirty="0"/>
           </a:p>
@@ -9154,7 +9043,7 @@
             <a:fld id="{418F7AD7-DC47-44A0-A9D7-F1C17BFD6F09}" type="slidenum">
               <a:rPr lang="de-AT" smtClean="0"/>
               <a:pPr/>
-              <a:t>‹Nr.›</a:t>
+              <a:t>‹#›</a:t>
             </a:fld>
             <a:endParaRPr lang="de-AT" dirty="0"/>
           </a:p>
@@ -9525,7 +9414,7 @@
             <a:fld id="{418F7AD7-DC47-44A0-A9D7-F1C17BFD6F09}" type="slidenum">
               <a:rPr lang="de-AT" smtClean="0"/>
               <a:pPr/>
-              <a:t>‹Nr.›</a:t>
+              <a:t>‹#›</a:t>
             </a:fld>
             <a:endParaRPr lang="de-AT" dirty="0"/>
           </a:p>
@@ -9848,7 +9737,7 @@
             <a:fld id="{418F7AD7-DC47-44A0-A9D7-F1C17BFD6F09}" type="slidenum">
               <a:rPr lang="de-AT" smtClean="0"/>
               <a:pPr/>
-              <a:t>‹Nr.›</a:t>
+              <a:t>‹#›</a:t>
             </a:fld>
             <a:endParaRPr lang="de-AT" dirty="0"/>
           </a:p>
@@ -10123,7 +10012,7 @@
             <a:fld id="{418F7AD7-DC47-44A0-A9D7-F1C17BFD6F09}" type="slidenum">
               <a:rPr lang="de-AT" smtClean="0"/>
               <a:pPr/>
-              <a:t>‹Nr.›</a:t>
+              <a:t>‹#›</a:t>
             </a:fld>
             <a:endParaRPr lang="de-AT" dirty="0"/>
           </a:p>
@@ -10494,7 +10383,7 @@
             <a:fld id="{418F7AD7-DC47-44A0-A9D7-F1C17BFD6F09}" type="slidenum">
               <a:rPr lang="de-AT" smtClean="0"/>
               <a:pPr/>
-              <a:t>‹Nr.›</a:t>
+              <a:t>‹#›</a:t>
             </a:fld>
             <a:endParaRPr lang="de-AT" dirty="0"/>
           </a:p>
@@ -10797,7 +10686,7 @@
             <a:fld id="{418F7AD7-DC47-44A0-A9D7-F1C17BFD6F09}" type="slidenum">
               <a:rPr lang="de-AT" smtClean="0"/>
               <a:pPr/>
-              <a:t>‹Nr.›</a:t>
+              <a:t>‹#›</a:t>
             </a:fld>
             <a:endParaRPr lang="de-AT" dirty="0"/>
           </a:p>
@@ -11150,7 +11039,7 @@
             <a:fld id="{418F7AD7-DC47-44A0-A9D7-F1C17BFD6F09}" type="slidenum">
               <a:rPr lang="de-AT" smtClean="0"/>
               <a:pPr/>
-              <a:t>‹Nr.›</a:t>
+              <a:t>‹#›</a:t>
             </a:fld>
             <a:endParaRPr lang="de-AT" dirty="0"/>
           </a:p>
@@ -11641,7 +11530,7 @@
             <a:fld id="{418F7AD7-DC47-44A0-A9D7-F1C17BFD6F09}" type="slidenum">
               <a:rPr lang="de-AT" smtClean="0"/>
               <a:pPr/>
-              <a:t>‹Nr.›</a:t>
+              <a:t>‹#›</a:t>
             </a:fld>
             <a:endParaRPr lang="de-AT" dirty="0"/>
           </a:p>
@@ -11934,7 +11823,7 @@
             <a:fld id="{418F7AD7-DC47-44A0-A9D7-F1C17BFD6F09}" type="slidenum">
               <a:rPr lang="de-AT" smtClean="0"/>
               <a:pPr/>
-              <a:t>‹Nr.›</a:t>
+              <a:t>‹#›</a:t>
             </a:fld>
             <a:endParaRPr lang="de-AT" dirty="0"/>
           </a:p>
@@ -12413,7 +12302,7 @@
             <a:fld id="{418F7AD7-DC47-44A0-A9D7-F1C17BFD6F09}" type="slidenum">
               <a:rPr lang="de-AT" smtClean="0"/>
               <a:pPr/>
-              <a:t>‹Nr.›</a:t>
+              <a:t>‹#›</a:t>
             </a:fld>
             <a:endParaRPr lang="de-AT" dirty="0"/>
           </a:p>
@@ -12953,7 +12842,7 @@
             <a:fld id="{418F7AD7-DC47-44A0-A9D7-F1C17BFD6F09}" type="slidenum">
               <a:rPr lang="de-AT" smtClean="0"/>
               <a:pPr/>
-              <a:t>‹Nr.›</a:t>
+              <a:t>‹#›</a:t>
             </a:fld>
             <a:endParaRPr lang="de-AT" dirty="0"/>
           </a:p>
@@ -13588,7 +13477,7 @@
             <a:fld id="{418F7AD7-DC47-44A0-A9D7-F1C17BFD6F09}" type="slidenum">
               <a:rPr lang="de-AT" smtClean="0"/>
               <a:pPr/>
-              <a:t>‹Nr.›</a:t>
+              <a:t>‹#›</a:t>
             </a:fld>
             <a:endParaRPr lang="de-AT" dirty="0"/>
           </a:p>
@@ -13893,7 +13782,7 @@
             <a:fld id="{418F7AD7-DC47-44A0-A9D7-F1C17BFD6F09}" type="slidenum">
               <a:rPr lang="de-AT" smtClean="0"/>
               <a:pPr/>
-              <a:t>‹Nr.›</a:t>
+              <a:t>‹#›</a:t>
             </a:fld>
             <a:endParaRPr lang="de-AT" dirty="0"/>
           </a:p>
@@ -14398,9 +14287,29 @@
           <a:bodyPr/>
           <a:lstStyle/>
           <a:p>
-            <a:r>
+            <a:br>
               <a:rPr lang="en-GB" noProof="1"/>
-              <a:t>Multi-orbital dynamical vertex approximation (DΓA)</a:t>
+            </a:br>
+            <a:r>
+              <a:rPr lang="en-GB" noProof="1"/>
+              <a:t>Multi-orbital </a:t>
+            </a:r>
+            <a:br>
+              <a:rPr lang="en-GB" noProof="1"/>
+            </a:br>
+            <a:r>
+              <a:rPr lang="en-GB" noProof="1"/>
+              <a:t>dynamical vertex approximation (D</a:t>
+            </a:r>
+            <a:r>
+              <a:rPr lang="en-GB" sz="5800" noProof="1">
+                <a:latin typeface="Algerian" panose="04020705040A02060702" pitchFamily="82" charset="0"/>
+              </a:rPr>
+              <a:t>Γ</a:t>
+            </a:r>
+            <a:r>
+              <a:rPr lang="en-GB" noProof="1"/>
+              <a:t>A)</a:t>
             </a:r>
           </a:p>
         </p:txBody>
@@ -14443,38 +14352,6 @@
       </p:sp>
       <p:sp>
         <p:nvSpPr>
-          <p:cNvPr id="6" name="Textplatzhalter 5">
-            <a:extLst>
-              <a:ext uri="{FF2B5EF4-FFF2-40B4-BE49-F238E27FC236}">
-                <a16:creationId xmlns:a16="http://schemas.microsoft.com/office/drawing/2014/main" id="{BEBBC48B-484D-472E-91AC-ADA8035C69B2}"/>
-              </a:ext>
-            </a:extLst>
-          </p:cNvPr>
-          <p:cNvSpPr>
-            <a:spLocks noGrp="1"/>
-          </p:cNvSpPr>
-          <p:nvPr>
-            <p:ph type="body" sz="quarter" idx="10"/>
-            <p:custDataLst>
-              <p:tags r:id="rId3"/>
-            </p:custDataLst>
-          </p:nvPr>
-        </p:nvSpPr>
-        <p:spPr/>
-        <p:txBody>
-          <a:bodyPr/>
-          <a:lstStyle/>
-          <a:p>
-            <a:pPr lvl="0"/>
-            <a:r>
-              <a:rPr lang="en-GB" noProof="1"/>
-              <a:t>www.tuwien.at</a:t>
-            </a:r>
-          </a:p>
-        </p:txBody>
-      </p:sp>
-      <p:sp>
-        <p:nvSpPr>
           <p:cNvPr id="4" name="Textfeld 3">
             <a:extLst>
               <a:ext uri="{FF2B5EF4-FFF2-40B4-BE49-F238E27FC236}">
@@ -14523,6 +14400,83 @@
               <a:rPr lang="en-GB" dirty="0"/>
               <a:t>Eric Jacob, MSc</a:t>
             </a:r>
+          </a:p>
+        </p:txBody>
+      </p:sp>
+      <p:pic>
+        <p:nvPicPr>
+          <p:cNvPr id="7" name="Grafik 6">
+            <a:extLst>
+              <a:ext uri="{FF2B5EF4-FFF2-40B4-BE49-F238E27FC236}">
+                <a16:creationId xmlns:a16="http://schemas.microsoft.com/office/drawing/2014/main" id="{E8394CAE-FC0E-2CB9-92F3-329B6E1F2BAE}"/>
+              </a:ext>
+            </a:extLst>
+          </p:cNvPr>
+          <p:cNvPicPr>
+            <a:picLocks noChangeAspect="1"/>
+          </p:cNvPicPr>
+          <p:nvPr/>
+        </p:nvPicPr>
+        <p:blipFill>
+          <a:blip r:embed="rId5"/>
+          <a:srcRect l="8030" t="13225" r="29088" b="16959"/>
+          <a:stretch>
+            <a:fillRect/>
+          </a:stretch>
+        </p:blipFill>
+        <p:spPr>
+          <a:xfrm>
+            <a:off x="8870950" y="317123"/>
+            <a:ext cx="2981325" cy="2896339"/>
+          </a:xfrm>
+          <a:prstGeom prst="rect">
+            <a:avLst/>
+          </a:prstGeom>
+        </p:spPr>
+      </p:pic>
+      <p:sp>
+        <p:nvSpPr>
+          <p:cNvPr id="8" name="Textfeld 7">
+            <a:extLst>
+              <a:ext uri="{FF2B5EF4-FFF2-40B4-BE49-F238E27FC236}">
+                <a16:creationId xmlns:a16="http://schemas.microsoft.com/office/drawing/2014/main" id="{594135A6-9536-C02D-78DA-ACA70025DA22}"/>
+              </a:ext>
+            </a:extLst>
+          </p:cNvPr>
+          <p:cNvSpPr txBox="1"/>
+          <p:nvPr/>
+        </p:nvSpPr>
+        <p:spPr>
+          <a:xfrm>
+            <a:off x="9117647" y="317123"/>
+            <a:ext cx="533400" cy="923330"/>
+          </a:xfrm>
+          <a:prstGeom prst="rect">
+            <a:avLst/>
+          </a:prstGeom>
+          <a:noFill/>
+        </p:spPr>
+        <p:txBody>
+          <a:bodyPr wrap="square" rtlCol="0">
+            <a:spAutoFit/>
+          </a:bodyPr>
+          <a:lstStyle/>
+          <a:p>
+            <a:r>
+              <a:rPr lang="en-GB" sz="5400" b="1" noProof="1">
+                <a:solidFill>
+                  <a:schemeClr val="bg1"/>
+                </a:solidFill>
+                <a:latin typeface="Algerian" panose="04020705040A02060702" pitchFamily="82" charset="0"/>
+              </a:rPr>
+              <a:t>Γ</a:t>
+            </a:r>
+            <a:endParaRPr lang="en-GB" sz="5400" b="1" dirty="0">
+              <a:solidFill>
+                <a:schemeClr val="bg1"/>
+              </a:solidFill>
+              <a:latin typeface="Algerian" panose="04020705040A02060702" pitchFamily="82" charset="0"/>
+            </a:endParaRPr>
           </a:p>
         </p:txBody>
       </p:sp>
@@ -14577,7 +14531,7 @@
           <p:nvPr/>
         </p:nvPicPr>
         <p:blipFill>
-          <a:blip r:embed="rId7">
+          <a:blip r:embed="rId6">
             <a:extLst>
               <a:ext uri="{28A0092B-C50C-407E-A947-70E740481C1C}">
                 <a14:useLocalDpi xmlns:a14="http://schemas.microsoft.com/office/drawing/2010/main" val="0"/>
@@ -14591,8 +14545,8 @@
         </p:blipFill>
         <p:spPr>
           <a:xfrm>
-            <a:off x="7430256" y="332217"/>
-            <a:ext cx="4433730" cy="2434363"/>
+            <a:off x="5807945" y="0"/>
+            <a:ext cx="6384055" cy="3505200"/>
           </a:xfrm>
           <a:prstGeom prst="rect">
             <a:avLst/>
@@ -14620,7 +14574,7 @@
         </p:nvSpPr>
         <p:spPr>
           <a:xfrm>
-            <a:off x="1307065" y="1549399"/>
+            <a:off x="1307065" y="2025649"/>
             <a:ext cx="9289498" cy="828675"/>
           </a:xfrm>
         </p:spPr>
@@ -14657,7 +14611,7 @@
         <p:spPr>
           <a:xfrm>
             <a:off x="1308101" y="2628900"/>
-            <a:ext cx="8453574" cy="3095625"/>
+            <a:ext cx="8794749" cy="3095625"/>
           </a:xfrm>
         </p:spPr>
         <p:txBody>
@@ -14669,10 +14623,7 @@
                 <a:spcPts val="600"/>
               </a:spcAft>
             </a:pPr>
-            <a:r>
-              <a:rPr lang="en-GB" noProof="1"/>
-              <a:t>Unconventional superconductivity (e.g. cuprates, nickelates) requires treatment of non-local correlations beyond DMFT → DΓA</a:t>
-            </a:r>
+            <a:endParaRPr lang="en-GB" noProof="1"/>
           </a:p>
           <a:p>
             <a:pPr>
@@ -14682,7 +14633,17 @@
             </a:pPr>
             <a:r>
               <a:rPr lang="en-GB" noProof="1"/>
-              <a:t>Currently, DΓA &amp; superconductivity calculations only implemented for single bands [1, 2]</a:t>
+              <a:t>Unconventional superconductivity                                                 (e.g. in cuprates or nickelates) requires special treatment          DMFT → D</a:t>
+            </a:r>
+            <a:r>
+              <a:rPr lang="en-GB" sz="2400" noProof="1">
+                <a:latin typeface="Algerian" panose="04020705040A02060702" pitchFamily="82" charset="0"/>
+              </a:rPr>
+              <a:t>Γ</a:t>
+            </a:r>
+            <a:r>
+              <a:rPr lang="en-GB" noProof="1"/>
+              <a:t>A [1]</a:t>
             </a:r>
           </a:p>
           <a:p>
@@ -14693,69 +14654,44 @@
             </a:pPr>
             <a:r>
               <a:rPr lang="en-GB" noProof="1"/>
-              <a:t>Many correlated materials (e.g. La₃Ni₂O₇) need a multi-orbital description [3]</a:t>
-            </a:r>
-          </a:p>
-          <a:p>
+              <a:t>DΓA &amp; superconductivity only implemented for one orbital [2, 3]</a:t>
+            </a:r>
+          </a:p>
+          <a:p>
+            <a:pPr>
+              <a:spcAft>
+                <a:spcPts val="600"/>
+              </a:spcAft>
+            </a:pPr>
             <a:r>
               <a:rPr lang="en-GB" noProof="1"/>
-              <a:t>Calculations down to superconducting transition temperatures    → vertex asymptotics [4]</a:t>
-            </a:r>
-          </a:p>
-        </p:txBody>
-      </p:sp>
-      <p:sp>
-        <p:nvSpPr>
-          <p:cNvPr id="2" name="Fußzeilenplatzhalter 1">
-            <a:extLst>
-              <a:ext uri="{FF2B5EF4-FFF2-40B4-BE49-F238E27FC236}">
-                <a16:creationId xmlns:a16="http://schemas.microsoft.com/office/drawing/2014/main" id="{24C7923A-B98B-5F78-5CCF-05EDEC1B03DD}"/>
-              </a:ext>
-            </a:extLst>
-          </p:cNvPr>
-          <p:cNvSpPr>
-            <a:spLocks noGrp="1"/>
-          </p:cNvSpPr>
-          <p:nvPr>
-            <p:ph type="ftr" sz="quarter" idx="14"/>
+              <a:t>Many correlated materials (e.g. La₃Ni₂O₇) need a multi-orbital description [4]</a:t>
+            </a:r>
+          </a:p>
+          <a:p>
+            <a:r>
+              <a:rPr lang="en-GB" noProof="1"/>
+              <a:t>Calculations down to low temperatures → vertex asymptotics [5]</a:t>
+            </a:r>
+          </a:p>
+        </p:txBody>
+      </p:sp>
+      <p:sp>
+        <p:nvSpPr>
+          <p:cNvPr id="4" name="Foliennummernplatzhalter 3">
+            <a:extLst>
+              <a:ext uri="{FF2B5EF4-FFF2-40B4-BE49-F238E27FC236}">
+                <a16:creationId xmlns:a16="http://schemas.microsoft.com/office/drawing/2014/main" id="{270019E6-CE55-FF6F-1814-DF3C572629CA}"/>
+              </a:ext>
+            </a:extLst>
+          </p:cNvPr>
+          <p:cNvSpPr>
+            <a:spLocks noGrp="1"/>
+          </p:cNvSpPr>
+          <p:nvPr>
+            <p:ph type="sldNum" sz="quarter" idx="15"/>
             <p:custDataLst>
               <p:tags r:id="rId3"/>
-            </p:custDataLst>
-          </p:nvPr>
-        </p:nvSpPr>
-        <p:spPr>
-          <a:xfrm>
-            <a:off x="461963" y="6385768"/>
-            <a:ext cx="10134600" cy="288000"/>
-          </a:xfrm>
-        </p:spPr>
-        <p:txBody>
-          <a:bodyPr/>
-          <a:lstStyle/>
-          <a:p>
-            <a:r>
-              <a:rPr lang="en-GB" noProof="1"/>
-              <a:t>Diploma thesis, Peil Julian | November 2025</a:t>
-            </a:r>
-          </a:p>
-        </p:txBody>
-      </p:sp>
-      <p:sp>
-        <p:nvSpPr>
-          <p:cNvPr id="4" name="Foliennummernplatzhalter 3">
-            <a:extLst>
-              <a:ext uri="{FF2B5EF4-FFF2-40B4-BE49-F238E27FC236}">
-                <a16:creationId xmlns:a16="http://schemas.microsoft.com/office/drawing/2014/main" id="{270019E6-CE55-FF6F-1814-DF3C572629CA}"/>
-              </a:ext>
-            </a:extLst>
-          </p:cNvPr>
-          <p:cNvSpPr>
-            <a:spLocks noGrp="1"/>
-          </p:cNvSpPr>
-          <p:nvPr>
-            <p:ph type="sldNum" sz="quarter" idx="15"/>
-            <p:custDataLst>
-              <p:tags r:id="rId4"/>
             </p:custDataLst>
           </p:nvPr>
         </p:nvSpPr>
@@ -14792,8 +14728,8 @@
         </p:nvSpPr>
         <p:spPr>
           <a:xfrm>
-            <a:off x="11106025" y="769065"/>
-            <a:ext cx="163502" cy="169558"/>
+            <a:off x="11092984" y="608678"/>
+            <a:ext cx="312732" cy="324315"/>
           </a:xfrm>
           <a:prstGeom prst="ellipse">
             <a:avLst/>
@@ -14844,7 +14780,7 @@
         </p:nvSpPr>
         <p:spPr>
           <a:xfrm>
-            <a:off x="5157812" y="1036417"/>
+            <a:off x="3984870" y="1005441"/>
             <a:ext cx="1428259" cy="738664"/>
           </a:xfrm>
           <a:prstGeom prst="rect">
@@ -14889,8 +14825,8 @@
         </p:nvCxnSpPr>
         <p:spPr>
           <a:xfrm flipV="1">
-            <a:off x="6586071" y="869857"/>
-            <a:ext cx="4469925" cy="535892"/>
+            <a:off x="5413129" y="770835"/>
+            <a:ext cx="5616821" cy="603938"/>
           </a:xfrm>
           <a:prstGeom prst="straightConnector1">
             <a:avLst/>
@@ -14919,10 +14855,10 @@
       </p:cxnSp>
       <p:sp>
         <p:nvSpPr>
-          <p:cNvPr id="20" name="Textfeld 19">
-            <a:extLst>
-              <a:ext uri="{FF2B5EF4-FFF2-40B4-BE49-F238E27FC236}">
-                <a16:creationId xmlns:a16="http://schemas.microsoft.com/office/drawing/2014/main" id="{5FC7D81B-607F-CB3C-93AA-01490F6832CE}"/>
+          <p:cNvPr id="21" name="Textfeld 20">
+            <a:extLst>
+              <a:ext uri="{FF2B5EF4-FFF2-40B4-BE49-F238E27FC236}">
+                <a16:creationId xmlns:a16="http://schemas.microsoft.com/office/drawing/2014/main" id="{6880DABE-05A4-B9A7-4045-3273C8212DE7}"/>
               </a:ext>
             </a:extLst>
           </p:cNvPr>
@@ -14931,8 +14867,8 @@
         </p:nvSpPr>
         <p:spPr>
           <a:xfrm>
-            <a:off x="1216231" y="5786579"/>
-            <a:ext cx="3385039" cy="646331"/>
+            <a:off x="5568949" y="6232193"/>
+            <a:ext cx="3759537" cy="461665"/>
           </a:xfrm>
           <a:prstGeom prst="rect">
             <a:avLst/>
@@ -14946,31 +14882,61 @@
           <a:lstStyle/>
           <a:p>
             <a:r>
-              <a:rPr lang="en-GB" sz="1200" noProof="1"/>
-              <a:t>[1] P. Worm, </a:t>
-            </a:r>
-            <a:r>
-              <a:rPr lang="de-AT" sz="1200" dirty="0"/>
-              <a:t>10.5281/zenodo.10406493	</a:t>
-            </a:r>
-          </a:p>
-          <a:p>
-            <a:r>
-              <a:rPr lang="de-AT" sz="1200" dirty="0"/>
-              <a:t>[2] A. Galler et al., 10.1016/j.cpc.2019.07.012</a:t>
-            </a:r>
-          </a:p>
-          <a:p>
-            <a:endParaRPr lang="en-GB" sz="1200" dirty="0"/>
-          </a:p>
-        </p:txBody>
-      </p:sp>
-      <p:sp>
-        <p:nvSpPr>
-          <p:cNvPr id="21" name="Textfeld 20">
-            <a:extLst>
-              <a:ext uri="{FF2B5EF4-FFF2-40B4-BE49-F238E27FC236}">
-                <a16:creationId xmlns:a16="http://schemas.microsoft.com/office/drawing/2014/main" id="{6880DABE-05A4-B9A7-4045-3273C8212DE7}"/>
+              <a:rPr lang="de-AT" sz="1200" noProof="1">
+                <a:solidFill>
+                  <a:schemeClr val="bg1"/>
+                </a:solidFill>
+              </a:rPr>
+              <a:t>[4] H.Sun et al., </a:t>
+            </a:r>
+            <a:r>
+              <a:rPr lang="de-AT" sz="1200" dirty="0">
+                <a:solidFill>
+                  <a:schemeClr val="bg1"/>
+                </a:solidFill>
+              </a:rPr>
+              <a:t>Nature 621 (2023)</a:t>
+            </a:r>
+          </a:p>
+          <a:p>
+            <a:r>
+              <a:rPr lang="de-AT" sz="1200" dirty="0">
+                <a:solidFill>
+                  <a:schemeClr val="bg1"/>
+                </a:solidFill>
+              </a:rPr>
+              <a:t>[5] M. </a:t>
+            </a:r>
+            <a:r>
+              <a:rPr lang="de-AT" sz="1200" dirty="0" err="1">
+                <a:solidFill>
+                  <a:schemeClr val="bg1"/>
+                </a:solidFill>
+              </a:rPr>
+              <a:t>Kitatani</a:t>
+            </a:r>
+            <a:r>
+              <a:rPr lang="de-AT" sz="1200" dirty="0">
+                <a:solidFill>
+                  <a:schemeClr val="bg1"/>
+                </a:solidFill>
+              </a:rPr>
+              <a:t> et al., J. Phys. Mater 5 (2022)</a:t>
+            </a:r>
+            <a:endParaRPr lang="en-GB" sz="1200" noProof="1">
+              <a:solidFill>
+                <a:schemeClr val="bg1"/>
+              </a:solidFill>
+            </a:endParaRPr>
+          </a:p>
+        </p:txBody>
+      </p:sp>
+      <p:sp>
+        <p:nvSpPr>
+          <p:cNvPr id="16" name="Textfeld 15">
+            <a:extLst>
+              <a:ext uri="{FF2B5EF4-FFF2-40B4-BE49-F238E27FC236}">
+                <a16:creationId xmlns:a16="http://schemas.microsoft.com/office/drawing/2014/main" id="{FAD14679-2E79-6AF0-F358-460A5158A2AD}"/>
               </a:ext>
             </a:extLst>
           </p:cNvPr>
@@ -14979,8 +14945,8 @@
         </p:nvSpPr>
         <p:spPr>
           <a:xfrm>
-            <a:off x="4706302" y="5786579"/>
-            <a:ext cx="3759537" cy="646331"/>
+            <a:off x="1307065" y="6242926"/>
+            <a:ext cx="3965189" cy="1015663"/>
           </a:xfrm>
           <a:prstGeom prst="rect">
             <a:avLst/>
@@ -14994,31 +14960,92 @@
           <a:lstStyle/>
           <a:p>
             <a:r>
-              <a:rPr lang="de-AT" sz="1200" noProof="1"/>
-              <a:t>[3] H.Sun et al., </a:t>
-            </a:r>
-            <a:r>
-              <a:rPr lang="de-AT" sz="1200" dirty="0"/>
-              <a:t>10.1038/s41586-023-06408-7</a:t>
-            </a:r>
-          </a:p>
-          <a:p>
-            <a:r>
-              <a:rPr lang="de-AT" sz="1200" dirty="0"/>
-              <a:t>[4] M. </a:t>
-            </a:r>
-            <a:r>
-              <a:rPr lang="de-AT" sz="1200" dirty="0" err="1"/>
-              <a:t>Kitatani</a:t>
-            </a:r>
-            <a:r>
-              <a:rPr lang="de-AT" sz="1200" dirty="0"/>
-              <a:t> et al., 10.1088/2515-7639/ac7e6d</a:t>
-            </a:r>
-            <a:endParaRPr lang="en-GB" sz="1200" noProof="1"/>
-          </a:p>
-          <a:p>
-            <a:endParaRPr lang="en-GB" sz="1200" dirty="0"/>
+              <a:rPr lang="en-GB" sz="1200" noProof="1">
+                <a:solidFill>
+                  <a:schemeClr val="bg1"/>
+                </a:solidFill>
+              </a:rPr>
+              <a:t>[1] G. Rohringer et. al., Rev. Mod. Phys. 90 (2018)</a:t>
+            </a:r>
+            <a:endParaRPr lang="de-AT" sz="1200" dirty="0">
+              <a:solidFill>
+                <a:schemeClr val="bg1"/>
+              </a:solidFill>
+            </a:endParaRPr>
+          </a:p>
+          <a:p>
+            <a:r>
+              <a:rPr lang="de-AT" sz="1200" dirty="0">
+                <a:solidFill>
+                  <a:schemeClr val="bg1"/>
+                </a:solidFill>
+              </a:rPr>
+              <a:t>[2] </a:t>
+            </a:r>
+            <a:r>
+              <a:rPr lang="en-GB" sz="1200" noProof="1">
+                <a:solidFill>
+                  <a:schemeClr val="bg1"/>
+                </a:solidFill>
+              </a:rPr>
+              <a:t>P. Worm, </a:t>
+            </a:r>
+            <a:r>
+              <a:rPr lang="de-AT" sz="1200" dirty="0" err="1">
+                <a:solidFill>
+                  <a:schemeClr val="bg1"/>
+                </a:solidFill>
+              </a:rPr>
+              <a:t>Zenodo</a:t>
+            </a:r>
+            <a:r>
+              <a:rPr lang="de-AT" sz="1200" dirty="0">
+                <a:solidFill>
+                  <a:schemeClr val="bg1"/>
+                </a:solidFill>
+              </a:rPr>
+              <a:t> (2023)</a:t>
+            </a:r>
+          </a:p>
+          <a:p>
+            <a:r>
+              <a:rPr lang="de-AT" sz="1200" dirty="0">
+                <a:solidFill>
+                  <a:schemeClr val="bg1"/>
+                </a:solidFill>
+              </a:rPr>
+              <a:t>[3] A. Galler et al., </a:t>
+            </a:r>
+            <a:r>
+              <a:rPr lang="de-AT" sz="1200" dirty="0" err="1">
+                <a:solidFill>
+                  <a:schemeClr val="bg1"/>
+                </a:solidFill>
+              </a:rPr>
+              <a:t>Comput</a:t>
+            </a:r>
+            <a:r>
+              <a:rPr lang="de-AT" sz="1200" dirty="0">
+                <a:solidFill>
+                  <a:schemeClr val="bg1"/>
+                </a:solidFill>
+              </a:rPr>
+              <a:t>. Phys. Commun. 245 (2019)</a:t>
+            </a:r>
+          </a:p>
+          <a:p>
+            <a:endParaRPr lang="de-AT" sz="1200" dirty="0">
+              <a:solidFill>
+                <a:schemeClr val="bg1"/>
+              </a:solidFill>
+            </a:endParaRPr>
+          </a:p>
+          <a:p>
+            <a:endParaRPr lang="en-GB" sz="1200" dirty="0">
+              <a:solidFill>
+                <a:schemeClr val="bg1"/>
+              </a:solidFill>
+            </a:endParaRPr>
           </a:p>
         </p:txBody>
       </p:sp>
@@ -15068,7 +15095,7 @@
                                         <p:tgtEl>
                                           <p:spTgt spid="9">
                                             <p:txEl>
-                                              <p:pRg st="0" end="0"/>
+                                              <p:pRg st="1" end="1"/>
                                             </p:txEl>
                                           </p:spTgt>
                                         </p:tgtEl>
@@ -15117,7 +15144,7 @@
                                         <p:tgtEl>
                                           <p:spTgt spid="9">
                                             <p:txEl>
-                                              <p:pRg st="1" end="1"/>
+                                              <p:pRg st="2" end="2"/>
                                             </p:txEl>
                                           </p:spTgt>
                                         </p:tgtEl>
@@ -15151,7 +15178,7 @@
                             </p:stCondLst>
                             <p:childTnLst>
                               <p:par>
-                                <p:cTn id="13" presetID="1" presetClass="entr" presetSubtype="0" fill="hold" grpId="0" nodeType="clickEffect">
+                                <p:cTn id="13" presetID="1" presetClass="entr" presetSubtype="0" fill="hold" nodeType="clickEffect">
                                   <p:stCondLst>
                                     <p:cond delay="0"/>
                                   </p:stCondLst>
@@ -15159,6 +15186,37 @@
                                     <p:set>
                                       <p:cBhvr>
                                         <p:cTn id="14" dur="1" fill="hold">
+                                          <p:stCondLst>
+                                            <p:cond delay="0"/>
+                                          </p:stCondLst>
+                                        </p:cTn>
+                                        <p:tgtEl>
+                                          <p:spTgt spid="9">
+                                            <p:txEl>
+                                              <p:pRg st="3" end="3"/>
+                                            </p:txEl>
+                                          </p:spTgt>
+                                        </p:tgtEl>
+                                        <p:attrNameLst>
+                                          <p:attrName>style.visibility</p:attrName>
+                                        </p:attrNameLst>
+                                      </p:cBhvr>
+                                      <p:to>
+                                        <p:strVal val="visible"/>
+                                      </p:to>
+                                    </p:set>
+                                  </p:childTnLst>
+                                </p:cTn>
+                              </p:par>
+                              <p:par>
+                                <p:cTn id="15" presetID="1" presetClass="entr" presetSubtype="0" fill="hold" grpId="0" nodeType="withEffect">
+                                  <p:stCondLst>
+                                    <p:cond delay="0"/>
+                                  </p:stCondLst>
+                                  <p:childTnLst>
+                                    <p:set>
+                                      <p:cBhvr>
+                                        <p:cTn id="16" dur="1" fill="hold">
                                           <p:stCondLst>
                                             <p:cond delay="0"/>
                                           </p:stCondLst>
@@ -15178,14 +15236,14 @@
                                 </p:cTn>
                               </p:par>
                               <p:par>
-                                <p:cTn id="15" presetID="1" presetClass="entr" presetSubtype="0" fill="hold" nodeType="withEffect">
+                                <p:cTn id="17" presetID="1" presetClass="entr" presetSubtype="0" fill="hold" nodeType="withEffect">
                                   <p:stCondLst>
                                     <p:cond delay="0"/>
                                   </p:stCondLst>
                                   <p:childTnLst>
                                     <p:set>
                                       <p:cBhvr>
-                                        <p:cTn id="16" dur="1" fill="hold">
+                                        <p:cTn id="18" dur="1" fill="hold">
                                           <p:stCondLst>
                                             <p:cond delay="0"/>
                                           </p:stCondLst>
@@ -15205,34 +15263,7 @@
                                 </p:cTn>
                               </p:par>
                               <p:par>
-                                <p:cTn id="17" presetID="1" presetClass="entr" presetSubtype="0" fill="hold" grpId="0" nodeType="withEffect">
-                                  <p:stCondLst>
-                                    <p:cond delay="0"/>
-                                  </p:stCondLst>
-                                  <p:childTnLst>
-                                    <p:set>
-                                      <p:cBhvr>
-                                        <p:cTn id="18" dur="1" fill="hold">
-                                          <p:stCondLst>
-                                            <p:cond delay="0"/>
-                                          </p:stCondLst>
-                                        </p:cTn>
-                                        <p:tgtEl>
-                                          <p:spTgt spid="3"/>
-                                        </p:tgtEl>
-                                        <p:attrNameLst>
-                                          <p:attrName>style.visibility</p:attrName>
-                                        </p:attrNameLst>
-                                      </p:cBhvr>
-                                      <p:to>
-                                        <p:strVal val="visible"/>
-                                      </p:to>
-                                    </p:set>
-                                  </p:childTnLst>
-                                </p:cTn>
-                              </p:par>
-                              <p:par>
-                                <p:cTn id="19" presetID="1" presetClass="entr" presetSubtype="0" fill="hold" nodeType="withEffect">
+                                <p:cTn id="19" presetID="1" presetClass="entr" presetSubtype="0" fill="hold" grpId="0" nodeType="withEffect">
                                   <p:stCondLst>
                                     <p:cond delay="0"/>
                                   </p:stCondLst>
@@ -15245,7 +15276,7 @@
                                           </p:stCondLst>
                                         </p:cTn>
                                         <p:tgtEl>
-                                          <p:spTgt spid="6"/>
+                                          <p:spTgt spid="3"/>
                                         </p:tgtEl>
                                         <p:attrNameLst>
                                           <p:attrName>style.visibility</p:attrName>
@@ -15272,11 +15303,7 @@
                                           </p:stCondLst>
                                         </p:cTn>
                                         <p:tgtEl>
-                                          <p:spTgt spid="9">
-                                            <p:txEl>
-                                              <p:pRg st="2" end="2"/>
-                                            </p:txEl>
-                                          </p:spTgt>
+                                          <p:spTgt spid="6"/>
                                         </p:tgtEl>
                                         <p:attrNameLst>
                                           <p:attrName>style.visibility</p:attrName>
@@ -15323,7 +15350,7 @@
                                         <p:tgtEl>
                                           <p:spTgt spid="9">
                                             <p:txEl>
-                                              <p:pRg st="3" end="3"/>
+                                              <p:pRg st="4" end="4"/>
                                             </p:txEl>
                                           </p:spTgt>
                                         </p:tgtEl>
@@ -15431,13 +15458,13 @@
             </a:r>
             <a:r>
               <a:rPr lang="en-GB" b="0" baseline="30000" noProof="1"/>
-              <a:t>[5]</a:t>
-            </a:r>
-          </a:p>
-        </p:txBody>
-      </p:sp>
-      <mc:AlternateContent xmlns:mc="http://schemas.openxmlformats.org/markup-compatibility/2006">
-        <mc:Choice xmlns:a14="http://schemas.microsoft.com/office/drawing/2010/main" Requires="a14">
+              <a:t>[6]</a:t>
+            </a:r>
+          </a:p>
+        </p:txBody>
+      </p:sp>
+      <mc:AlternateContent xmlns:mc="http://schemas.openxmlformats.org/markup-compatibility/2006" xmlns:a14="http://schemas.microsoft.com/office/drawing/2010/main">
+        <mc:Choice Requires="a14">
           <p:sp>
             <p:nvSpPr>
               <p:cNvPr id="9" name="Inhaltsplatzhalter 8">
@@ -15609,9 +15636,8 @@
                         <m:r>
                           <a:rPr lang="de-AT" b="0" i="1" noProof="1" smtClean="0">
                             <a:latin typeface="Cambria Math" panose="02040503050406030204" pitchFamily="18" charset="0"/>
-                            <a:ea typeface="Cambria Math" panose="02040503050406030204" pitchFamily="18" charset="0"/>
                           </a:rPr>
-                          <m:t>'</m:t>
+                          <m:t>′</m:t>
                         </m:r>
                       </m:sup>
                     </m:sSup>
@@ -15663,9 +15689,8 @@
                         <m:r>
                           <a:rPr lang="de-AT" b="0" i="1" noProof="1" smtClean="0">
                             <a:latin typeface="Cambria Math" panose="02040503050406030204" pitchFamily="18" charset="0"/>
-                            <a:ea typeface="Cambria Math" panose="02040503050406030204" pitchFamily="18" charset="0"/>
                           </a:rPr>
-                          <m:t>’</m:t>
+                          <m:t>′</m:t>
                         </m:r>
                       </m:sup>
                     </m:sSubSup>
@@ -15781,11 +15806,10 @@
                           <m:t>qkk</m:t>
                         </m:r>
                         <m:r>
-                          <a:rPr lang="de-AT" i="1" noProof="1">
+                          <a:rPr lang="de-AT" b="0" i="1" noProof="1" smtClean="0">
                             <a:latin typeface="Cambria Math" panose="02040503050406030204" pitchFamily="18" charset="0"/>
-                            <a:ea typeface="Cambria Math" panose="02040503050406030204" pitchFamily="18" charset="0"/>
                           </a:rPr>
-                          <m:t>’</m:t>
+                          <m:t>′</m:t>
                         </m:r>
                       </m:sup>
                     </m:sSubSup>
@@ -15959,11 +15983,10 @@
                           <m:t>k</m:t>
                         </m:r>
                         <m:r>
-                          <a:rPr lang="de-AT" i="1" noProof="1">
+                          <a:rPr lang="de-AT" b="0" i="1" noProof="1" smtClean="0">
                             <a:latin typeface="Cambria Math" panose="02040503050406030204" pitchFamily="18" charset="0"/>
-                            <a:ea typeface="Cambria Math" panose="02040503050406030204" pitchFamily="18" charset="0"/>
                           </a:rPr>
-                          <m:t>’</m:t>
+                          <m:t>′</m:t>
                         </m:r>
                       </m:sup>
                     </m:sSubSup>
@@ -15996,7 +16019,7 @@
             </p:txBody>
           </p:sp>
         </mc:Choice>
-        <mc:Fallback>
+        <mc:Fallback xmlns="">
           <p:sp>
             <p:nvSpPr>
               <p:cNvPr id="9" name="Inhaltsplatzhalter 8">
@@ -16012,7 +16035,7 @@
               <p:nvPr>
                 <p:ph idx="1"/>
                 <p:custDataLst>
-                  <p:tags r:id="rId2"/>
+                  <p:tags r:id="rId6"/>
                 </p:custDataLst>
               </p:nvPr>
             </p:nvSpPr>
@@ -16045,56 +16068,20 @@
       </mc:AlternateContent>
       <p:sp>
         <p:nvSpPr>
-          <p:cNvPr id="2" name="Fußzeilenplatzhalter 1">
-            <a:extLst>
-              <a:ext uri="{FF2B5EF4-FFF2-40B4-BE49-F238E27FC236}">
-                <a16:creationId xmlns:a16="http://schemas.microsoft.com/office/drawing/2014/main" id="{CB31B968-0E40-9416-ADE9-4779DB691155}"/>
-              </a:ext>
-            </a:extLst>
-          </p:cNvPr>
-          <p:cNvSpPr>
-            <a:spLocks noGrp="1"/>
-          </p:cNvSpPr>
-          <p:nvPr>
-            <p:ph type="ftr" sz="quarter" idx="14"/>
+          <p:cNvPr id="4" name="Foliennummernplatzhalter 3">
+            <a:extLst>
+              <a:ext uri="{FF2B5EF4-FFF2-40B4-BE49-F238E27FC236}">
+                <a16:creationId xmlns:a16="http://schemas.microsoft.com/office/drawing/2014/main" id="{DD8DA1A2-6901-775A-8979-33F7C42E2D0B}"/>
+              </a:ext>
+            </a:extLst>
+          </p:cNvPr>
+          <p:cNvSpPr>
+            <a:spLocks noGrp="1"/>
+          </p:cNvSpPr>
+          <p:nvPr>
+            <p:ph type="sldNum" sz="quarter" idx="15"/>
             <p:custDataLst>
               <p:tags r:id="rId3"/>
-            </p:custDataLst>
-          </p:nvPr>
-        </p:nvSpPr>
-        <p:spPr>
-          <a:xfrm>
-            <a:off x="461963" y="6385768"/>
-            <a:ext cx="10134600" cy="288000"/>
-          </a:xfrm>
-        </p:spPr>
-        <p:txBody>
-          <a:bodyPr/>
-          <a:lstStyle/>
-          <a:p>
-            <a:r>
-              <a:rPr lang="en-GB" noProof="1"/>
-              <a:t>Diploma thesis, Peil Julian | November 2025</a:t>
-            </a:r>
-          </a:p>
-        </p:txBody>
-      </p:sp>
-      <p:sp>
-        <p:nvSpPr>
-          <p:cNvPr id="4" name="Foliennummernplatzhalter 3">
-            <a:extLst>
-              <a:ext uri="{FF2B5EF4-FFF2-40B4-BE49-F238E27FC236}">
-                <a16:creationId xmlns:a16="http://schemas.microsoft.com/office/drawing/2014/main" id="{DD8DA1A2-6901-775A-8979-33F7C42E2D0B}"/>
-              </a:ext>
-            </a:extLst>
-          </p:cNvPr>
-          <p:cNvSpPr>
-            <a:spLocks noGrp="1"/>
-          </p:cNvSpPr>
-          <p:nvPr>
-            <p:ph type="sldNum" sz="quarter" idx="15"/>
-            <p:custDataLst>
-              <p:tags r:id="rId4"/>
             </p:custDataLst>
           </p:nvPr>
         </p:nvSpPr>
@@ -16145,7 +16132,7 @@
         </p:blipFill>
         <p:spPr>
           <a:xfrm>
-            <a:off x="7363644" y="809073"/>
+            <a:off x="7560494" y="1199291"/>
             <a:ext cx="4082481" cy="1528889"/>
           </a:xfrm>
           <a:prstGeom prst="rect">
@@ -16167,7 +16154,7 @@
         </p:nvSpPr>
         <p:spPr>
           <a:xfrm>
-            <a:off x="1216231" y="5786579"/>
+            <a:off x="1307065" y="6252769"/>
             <a:ext cx="3385039" cy="276999"/>
           </a:xfrm>
           <a:prstGeom prst="rect">
@@ -16182,10 +16169,18 @@
           <a:lstStyle/>
           <a:p>
             <a:r>
-              <a:rPr lang="en-GB" sz="1200" noProof="1"/>
-              <a:t>[5] https://github.com/Julpe/moLDGA</a:t>
-            </a:r>
-            <a:endParaRPr lang="en-GB" sz="1200" dirty="0"/>
+              <a:rPr lang="en-GB" sz="1200" noProof="1">
+                <a:solidFill>
+                  <a:schemeClr val="bg1"/>
+                </a:solidFill>
+              </a:rPr>
+              <a:t>[6] https://github.com/Julpe/moLDGA</a:t>
+            </a:r>
+            <a:endParaRPr lang="en-GB" sz="1200" dirty="0">
+              <a:solidFill>
+                <a:schemeClr val="bg1"/>
+              </a:solidFill>
+            </a:endParaRPr>
           </a:p>
         </p:txBody>
       </p:sp>
@@ -16741,7 +16736,7 @@
             </a:pPr>
             <a:r>
               <a:rPr lang="de-DE" noProof="1"/>
-              <a:t>Benchmarks against multi-orbital calculations performed by [2] (SrVO</a:t>
+              <a:t>Benchmarks against multi-orbital calculations performed by [2, 7] (SrVO</a:t>
             </a:r>
             <a:r>
               <a:rPr lang="de-DE" sz="2400" noProof="1"/>
@@ -16766,42 +16761,6 @@
       </p:sp>
       <p:sp>
         <p:nvSpPr>
-          <p:cNvPr id="5" name="Fußzeilenplatzhalter 4">
-            <a:extLst>
-              <a:ext uri="{FF2B5EF4-FFF2-40B4-BE49-F238E27FC236}">
-                <a16:creationId xmlns:a16="http://schemas.microsoft.com/office/drawing/2014/main" id="{B4666583-2E2D-4DC1-906C-9AC4DEEBB2E4}"/>
-              </a:ext>
-            </a:extLst>
-          </p:cNvPr>
-          <p:cNvSpPr>
-            <a:spLocks noGrp="1"/>
-          </p:cNvSpPr>
-          <p:nvPr>
-            <p:ph type="ftr" sz="quarter" idx="16"/>
-            <p:custDataLst>
-              <p:tags r:id="rId6"/>
-            </p:custDataLst>
-          </p:nvPr>
-        </p:nvSpPr>
-        <p:spPr>
-          <a:xfrm>
-            <a:off x="461963" y="6385768"/>
-            <a:ext cx="10134600" cy="288000"/>
-          </a:xfrm>
-        </p:spPr>
-        <p:txBody>
-          <a:bodyPr/>
-          <a:lstStyle/>
-          <a:p>
-            <a:r>
-              <a:rPr lang="en-GB" noProof="1"/>
-              <a:t>Diploma thesis, Peil Julian | November 2025</a:t>
-            </a:r>
-          </a:p>
-        </p:txBody>
-      </p:sp>
-      <p:sp>
-        <p:nvSpPr>
           <p:cNvPr id="16" name="Textfeld 15">
             <a:extLst>
               <a:ext uri="{FF2B5EF4-FFF2-40B4-BE49-F238E27FC236}">
@@ -16814,8 +16773,8 @@
         </p:nvSpPr>
         <p:spPr>
           <a:xfrm>
-            <a:off x="1216231" y="5786579"/>
-            <a:ext cx="3385039" cy="646331"/>
+            <a:off x="1308100" y="6211669"/>
+            <a:ext cx="3930019" cy="461665"/>
           </a:xfrm>
           <a:prstGeom prst="rect">
             <a:avLst/>
@@ -16829,18 +16788,79 @@
           <a:lstStyle/>
           <a:p>
             <a:r>
-              <a:rPr lang="de-DE" sz="1200" noProof="1"/>
-              <a:t>[1] P. Worm, 10.5281/zenodo.10406493	</a:t>
-            </a:r>
-          </a:p>
-          <a:p>
-            <a:r>
-              <a:rPr lang="de-DE" sz="1200" noProof="1"/>
-              <a:t>[2] A. Galler et al., 10.1016/j.cpc.2019.07.012</a:t>
-            </a:r>
-          </a:p>
-          <a:p>
-            <a:endParaRPr lang="de-DE" sz="1200" noProof="1"/>
+              <a:rPr lang="de-DE" sz="1200" noProof="1">
+                <a:solidFill>
+                  <a:schemeClr val="bg1"/>
+                </a:solidFill>
+              </a:rPr>
+              <a:t>[1] </a:t>
+            </a:r>
+            <a:r>
+              <a:rPr lang="en-GB" sz="1200" noProof="1">
+                <a:solidFill>
+                  <a:schemeClr val="bg1"/>
+                </a:solidFill>
+              </a:rPr>
+              <a:t>P. Worm, </a:t>
+            </a:r>
+            <a:r>
+              <a:rPr lang="de-AT" sz="1200" dirty="0" err="1">
+                <a:solidFill>
+                  <a:schemeClr val="bg1"/>
+                </a:solidFill>
+              </a:rPr>
+              <a:t>Zenodo</a:t>
+            </a:r>
+            <a:r>
+              <a:rPr lang="de-AT" sz="1200" dirty="0">
+                <a:solidFill>
+                  <a:schemeClr val="bg1"/>
+                </a:solidFill>
+              </a:rPr>
+              <a:t> (2023)</a:t>
+            </a:r>
+            <a:r>
+              <a:rPr lang="de-DE" sz="1200" noProof="1">
+                <a:solidFill>
+                  <a:schemeClr val="bg1"/>
+                </a:solidFill>
+              </a:rPr>
+              <a:t>	</a:t>
+            </a:r>
+          </a:p>
+          <a:p>
+            <a:r>
+              <a:rPr lang="de-DE" sz="1200" noProof="1">
+                <a:solidFill>
+                  <a:schemeClr val="bg1"/>
+                </a:solidFill>
+              </a:rPr>
+              <a:t>[2] </a:t>
+            </a:r>
+            <a:r>
+              <a:rPr lang="de-AT" sz="1200" dirty="0">
+                <a:solidFill>
+                  <a:schemeClr val="bg1"/>
+                </a:solidFill>
+              </a:rPr>
+              <a:t>A. Galler et al., </a:t>
+            </a:r>
+            <a:r>
+              <a:rPr lang="de-AT" sz="1200" dirty="0" err="1">
+                <a:solidFill>
+                  <a:schemeClr val="bg1"/>
+                </a:solidFill>
+              </a:rPr>
+              <a:t>Comput</a:t>
+            </a:r>
+            <a:r>
+              <a:rPr lang="de-AT" sz="1200" dirty="0">
+                <a:solidFill>
+                  <a:schemeClr val="bg1"/>
+                </a:solidFill>
+              </a:rPr>
+              <a:t>. Phys. Commun. 245 (2019)</a:t>
+            </a:r>
           </a:p>
         </p:txBody>
       </p:sp>
@@ -16859,7 +16879,7 @@
           <p:nvPr/>
         </p:nvPicPr>
         <p:blipFill>
-          <a:blip r:embed="rId9">
+          <a:blip r:embed="rId8">
             <a:extLst>
               <a:ext uri="{28A0092B-C50C-407E-A947-70E740481C1C}">
                 <a14:useLocalDpi xmlns:a14="http://schemas.microsoft.com/office/drawing/2010/main" val="0"/>
@@ -16895,7 +16915,7 @@
           <p:nvPr/>
         </p:nvPicPr>
         <p:blipFill>
-          <a:blip r:embed="rId9">
+          <a:blip r:embed="rId8">
             <a:extLst>
               <a:ext uri="{28A0092B-C50C-407E-A947-70E740481C1C}">
                 <a14:useLocalDpi xmlns:a14="http://schemas.microsoft.com/office/drawing/2010/main" val="0"/>
@@ -16931,7 +16951,7 @@
           <p:nvPr/>
         </p:nvPicPr>
         <p:blipFill>
-          <a:blip r:embed="rId10"/>
+          <a:blip r:embed="rId9"/>
           <a:stretch>
             <a:fillRect/>
           </a:stretch>
@@ -16960,8 +16980,8 @@
         </p:nvSpPr>
         <p:spPr>
           <a:xfrm>
-            <a:off x="4706302" y="5786579"/>
-            <a:ext cx="3759537" cy="276999"/>
+            <a:off x="5569078" y="6238886"/>
+            <a:ext cx="3759537" cy="461665"/>
           </a:xfrm>
           <a:prstGeom prst="rect">
             <a:avLst/>
@@ -16975,14 +16995,31 @@
           <a:lstStyle/>
           <a:p>
             <a:r>
-              <a:rPr lang="de-AT" sz="1200" noProof="1"/>
-              <a:t>[6] Y. Zhang et al., </a:t>
-            </a:r>
-            <a:r>
-              <a:rPr lang="de-AT" sz="1200" dirty="0"/>
-              <a:t>10.1038/s41567-024-02515-y</a:t>
-            </a:r>
-            <a:endParaRPr lang="en-GB" sz="1200" dirty="0"/>
+              <a:rPr lang="de-AT" sz="1200" dirty="0">
+                <a:solidFill>
+                  <a:schemeClr val="bg1"/>
+                </a:solidFill>
+              </a:rPr>
+              <a:t>[7] J. Kaufmann et. al., Phys. Rev. B 103 (2021)  </a:t>
+            </a:r>
+          </a:p>
+          <a:p>
+            <a:r>
+              <a:rPr lang="de-AT" sz="1200" noProof="1">
+                <a:solidFill>
+                  <a:schemeClr val="bg1"/>
+                </a:solidFill>
+              </a:rPr>
+              <a:t>[8] Y. Zhang et al., </a:t>
+            </a:r>
+            <a:r>
+              <a:rPr lang="de-AT" sz="1200" dirty="0">
+                <a:solidFill>
+                  <a:schemeClr val="bg1"/>
+                </a:solidFill>
+              </a:rPr>
+              <a:t>Nature 20 (2024)</a:t>
+            </a:r>
           </a:p>
         </p:txBody>
       </p:sp>
@@ -17016,7 +17053,7 @@
           <a:p>
             <a:r>
               <a:rPr lang="en-GB" sz="2200" dirty="0"/>
-              <a:t>[6]</a:t>
+              <a:t>[8]</a:t>
             </a:r>
           </a:p>
         </p:txBody>
@@ -17474,13 +17511,7 @@
   <p:cSld>
     <p:spTree>
       <p:nvGrpSpPr>
-        <p:cNvPr id="1" name="">
-          <a:extLst>
-            <a:ext uri="{FF2B5EF4-FFF2-40B4-BE49-F238E27FC236}">
-              <a16:creationId xmlns:a16="http://schemas.microsoft.com/office/drawing/2014/main" id="{5CF268ED-74AE-823B-781E-77FE1AA9529A}"/>
-            </a:ext>
-          </a:extLst>
-        </p:cNvPr>
+        <p:cNvPr id="1" name=""/>
         <p:cNvGrpSpPr/>
         <p:nvPr/>
       </p:nvGrpSpPr>
@@ -17497,54 +17528,44 @@
           <p:cNvPr id="2" name="Titel 1">
             <a:extLst>
               <a:ext uri="{FF2B5EF4-FFF2-40B4-BE49-F238E27FC236}">
-                <a16:creationId xmlns:a16="http://schemas.microsoft.com/office/drawing/2014/main" id="{A8C67E33-5D94-E00C-DEA9-C823E940524E}"/>
-              </a:ext>
-            </a:extLst>
-          </p:cNvPr>
-          <p:cNvSpPr>
-            <a:spLocks noGrp="1"/>
-          </p:cNvSpPr>
-          <p:nvPr>
-            <p:ph type="ctrTitle"/>
-            <p:custDataLst>
-              <p:tags r:id="rId1"/>
-            </p:custDataLst>
-          </p:nvPr>
-        </p:nvSpPr>
-        <p:spPr>
-          <a:xfrm>
-            <a:off x="1308100" y="2276475"/>
-            <a:ext cx="9577388" cy="1524000"/>
-          </a:xfrm>
-        </p:spPr>
+                <a16:creationId xmlns:a16="http://schemas.microsoft.com/office/drawing/2014/main" id="{6DAE98F1-6758-A7D6-7C88-E506D2E9268C}"/>
+              </a:ext>
+            </a:extLst>
+          </p:cNvPr>
+          <p:cNvSpPr>
+            <a:spLocks noGrp="1"/>
+          </p:cNvSpPr>
+          <p:nvPr>
+            <p:ph type="title"/>
+          </p:nvPr>
+        </p:nvSpPr>
+        <p:spPr/>
         <p:txBody>
           <a:bodyPr/>
           <a:lstStyle/>
           <a:p>
             <a:r>
               <a:rPr lang="en-GB" noProof="1"/>
-              <a:t>Thank you for your attention! Any questions?</a:t>
-            </a:r>
-          </a:p>
-        </p:txBody>
-      </p:sp>
-      <p:sp>
-        <p:nvSpPr>
-          <p:cNvPr id="6" name="Textplatzhalter 5">
-            <a:extLst>
-              <a:ext uri="{FF2B5EF4-FFF2-40B4-BE49-F238E27FC236}">
-                <a16:creationId xmlns:a16="http://schemas.microsoft.com/office/drawing/2014/main" id="{47E0BD82-6F65-DBC1-7A6A-8C8DB604FE51}"/>
-              </a:ext>
-            </a:extLst>
-          </p:cNvPr>
-          <p:cNvSpPr>
-            <a:spLocks noGrp="1"/>
-          </p:cNvSpPr>
-          <p:nvPr>
-            <p:ph type="body" sz="quarter" idx="10"/>
-            <p:custDataLst>
-              <p:tags r:id="rId2"/>
-            </p:custDataLst>
+              <a:t>Summary</a:t>
+            </a:r>
+            <a:endParaRPr lang="en-GB" dirty="0"/>
+          </a:p>
+        </p:txBody>
+      </p:sp>
+      <p:sp>
+        <p:nvSpPr>
+          <p:cNvPr id="3" name="Inhaltsplatzhalter 2">
+            <a:extLst>
+              <a:ext uri="{FF2B5EF4-FFF2-40B4-BE49-F238E27FC236}">
+                <a16:creationId xmlns:a16="http://schemas.microsoft.com/office/drawing/2014/main" id="{489E940E-9765-7A4E-94C8-7F75D0B16BA8}"/>
+              </a:ext>
+            </a:extLst>
+          </p:cNvPr>
+          <p:cNvSpPr>
+            <a:spLocks noGrp="1"/>
+          </p:cNvSpPr>
+          <p:nvPr>
+            <p:ph idx="1"/>
           </p:nvPr>
         </p:nvSpPr>
         <p:spPr/>
@@ -17552,18 +17573,152 @@
           <a:bodyPr/>
           <a:lstStyle/>
           <a:p>
-            <a:pPr lvl="0"/>
+            <a:r>
+              <a:rPr lang="en-GB" dirty="0"/>
+              <a:t>Motivation</a:t>
+            </a:r>
+          </a:p>
+          <a:p>
+            <a:pPr lvl="1"/>
+            <a:r>
+              <a:rPr lang="en-GB" dirty="0"/>
+              <a:t>Study realistic multi-orbital materials </a:t>
+            </a:r>
             <a:r>
               <a:rPr lang="en-GB" noProof="1"/>
-              <a:t>www.tuwien.at</a:t>
-            </a:r>
-          </a:p>
-        </p:txBody>
-      </p:sp>
+              <a:t>(e.g. La₃Ni₂O₇) with D</a:t>
+            </a:r>
+            <a:r>
+              <a:rPr lang="en-GB" sz="2200" noProof="1">
+                <a:latin typeface="Algerian" panose="04020705040A02060702" pitchFamily="82" charset="0"/>
+              </a:rPr>
+              <a:t>Γ</a:t>
+            </a:r>
+            <a:r>
+              <a:rPr lang="en-GB" noProof="1"/>
+              <a:t>A</a:t>
+            </a:r>
+          </a:p>
+          <a:p>
+            <a:r>
+              <a:rPr lang="en-GB" noProof="1"/>
+              <a:t>Implementation </a:t>
+            </a:r>
+          </a:p>
+          <a:p>
+            <a:pPr lvl="1"/>
+            <a:r>
+              <a:rPr lang="en-GB" noProof="1"/>
+              <a:t>Additional orbital degrees of freedom</a:t>
+            </a:r>
+          </a:p>
+          <a:p>
+            <a:pPr lvl="1"/>
+            <a:r>
+              <a:rPr lang="en-GB" noProof="1"/>
+              <a:t>Taking advantage of system symmetries</a:t>
+            </a:r>
+          </a:p>
+          <a:p>
+            <a:r>
+              <a:rPr lang="en-GB" noProof="1"/>
+              <a:t>Successful execution of benchmarks</a:t>
+            </a:r>
+          </a:p>
+          <a:p>
+            <a:pPr lvl="1"/>
+            <a:r>
+              <a:rPr lang="en-GB" noProof="1"/>
+              <a:t>Single- and two-orbital calculations</a:t>
+            </a:r>
+          </a:p>
+          <a:p>
+            <a:pPr marL="0" indent="0">
+              <a:buNone/>
+            </a:pPr>
+            <a:endParaRPr lang="en-GB" noProof="1"/>
+          </a:p>
+          <a:p>
+            <a:pPr marL="0" indent="0">
+              <a:buNone/>
+            </a:pPr>
+            <a:endParaRPr lang="en-GB" dirty="0"/>
+          </a:p>
+          <a:p>
+            <a:endParaRPr lang="en-GB" dirty="0"/>
+          </a:p>
+        </p:txBody>
+      </p:sp>
+      <p:sp>
+        <p:nvSpPr>
+          <p:cNvPr id="6" name="Foliennummernplatzhalter 5">
+            <a:extLst>
+              <a:ext uri="{FF2B5EF4-FFF2-40B4-BE49-F238E27FC236}">
+                <a16:creationId xmlns:a16="http://schemas.microsoft.com/office/drawing/2014/main" id="{65294F6C-7FF7-8244-7EE4-1FA13E7A52BF}"/>
+              </a:ext>
+            </a:extLst>
+          </p:cNvPr>
+          <p:cNvSpPr>
+            <a:spLocks noGrp="1"/>
+          </p:cNvSpPr>
+          <p:nvPr>
+            <p:ph type="sldNum" sz="quarter" idx="15"/>
+          </p:nvPr>
+        </p:nvSpPr>
+        <p:spPr/>
+        <p:txBody>
+          <a:bodyPr/>
+          <a:lstStyle/>
+          <a:p>
+            <a:fld id="{418F7AD7-DC47-44A0-A9D7-F1C17BFD6F09}" type="slidenum">
+              <a:rPr lang="de-AT" smtClean="0"/>
+              <a:pPr/>
+              <a:t>5</a:t>
+            </a:fld>
+            <a:endParaRPr lang="de-AT" dirty="0"/>
+          </a:p>
+        </p:txBody>
+      </p:sp>
+      <p:pic>
+        <p:nvPicPr>
+          <p:cNvPr id="7" name="Grafik 6" descr="Ein Bild, das Grafikdesign, Grafiken, Farbigkeit, Kunst enthält.&#10;&#10;KI-generierte Inhalte können fehlerhaft sein.">
+            <a:extLst>
+              <a:ext uri="{FF2B5EF4-FFF2-40B4-BE49-F238E27FC236}">
+                <a16:creationId xmlns:a16="http://schemas.microsoft.com/office/drawing/2014/main" id="{9F405751-EAA6-9F9A-187C-133CEB599531}"/>
+              </a:ext>
+            </a:extLst>
+          </p:cNvPr>
+          <p:cNvPicPr>
+            <a:picLocks noChangeAspect="1"/>
+          </p:cNvPicPr>
+          <p:nvPr/>
+        </p:nvPicPr>
+        <p:blipFill>
+          <a:blip r:embed="rId2">
+            <a:extLst>
+              <a:ext uri="{28A0092B-C50C-407E-A947-70E740481C1C}">
+                <a14:useLocalDpi xmlns:a14="http://schemas.microsoft.com/office/drawing/2010/main" val="0"/>
+              </a:ext>
+            </a:extLst>
+          </a:blip>
+          <a:stretch>
+            <a:fillRect/>
+          </a:stretch>
+        </p:blipFill>
+        <p:spPr>
+          <a:xfrm>
+            <a:off x="6299200" y="42009"/>
+            <a:ext cx="5215382" cy="2919965"/>
+          </a:xfrm>
+          <a:prstGeom prst="rect">
+            <a:avLst/>
+          </a:prstGeom>
+        </p:spPr>
+      </p:pic>
     </p:spTree>
     <p:extLst>
       <p:ext uri="{BB962C8B-B14F-4D97-AF65-F5344CB8AC3E}">
-        <p14:creationId xmlns:p14="http://schemas.microsoft.com/office/powerpoint/2010/main" val="2640984022"/>
+        <p14:creationId xmlns:p14="http://schemas.microsoft.com/office/powerpoint/2010/main" val="3701543700"/>
       </p:ext>
     </p:extLst>
   </p:cSld>
@@ -17573,6 +17728,152 @@
 </p:sld>
 </file>
 
+<file path=ppt/slides/slide6.xml><?xml version="1.0" encoding="utf-8"?>
+<p:sld xmlns:a="http://schemas.openxmlformats.org/drawingml/2006/main" xmlns:r="http://schemas.openxmlformats.org/officeDocument/2006/relationships" xmlns:p="http://schemas.openxmlformats.org/presentationml/2006/main">
+  <p:cSld>
+    <p:spTree>
+      <p:nvGrpSpPr>
+        <p:cNvPr id="1" name=""/>
+        <p:cNvGrpSpPr/>
+        <p:nvPr/>
+      </p:nvGrpSpPr>
+      <p:grpSpPr>
+        <a:xfrm>
+          <a:off x="0" y="0"/>
+          <a:ext cx="0" cy="0"/>
+          <a:chOff x="0" y="0"/>
+          <a:chExt cx="0" cy="0"/>
+        </a:xfrm>
+      </p:grpSpPr>
+      <p:sp>
+        <p:nvSpPr>
+          <p:cNvPr id="6" name="Titel 5">
+            <a:extLst>
+              <a:ext uri="{FF2B5EF4-FFF2-40B4-BE49-F238E27FC236}">
+                <a16:creationId xmlns:a16="http://schemas.microsoft.com/office/drawing/2014/main" id="{FD92750E-C788-BF81-DA82-6DFE38DEA1BA}"/>
+              </a:ext>
+            </a:extLst>
+          </p:cNvPr>
+          <p:cNvSpPr>
+            <a:spLocks noGrp="1"/>
+          </p:cNvSpPr>
+          <p:nvPr>
+            <p:ph type="title"/>
+          </p:nvPr>
+        </p:nvSpPr>
+        <p:spPr/>
+        <p:txBody>
+          <a:bodyPr/>
+          <a:lstStyle/>
+          <a:p>
+            <a:r>
+              <a:rPr lang="en-GB" dirty="0"/>
+              <a:t>Model</a:t>
+            </a:r>
+          </a:p>
+        </p:txBody>
+      </p:sp>
+      <p:sp>
+        <p:nvSpPr>
+          <p:cNvPr id="7" name="Inhaltsplatzhalter 6">
+            <a:extLst>
+              <a:ext uri="{FF2B5EF4-FFF2-40B4-BE49-F238E27FC236}">
+                <a16:creationId xmlns:a16="http://schemas.microsoft.com/office/drawing/2014/main" id="{5C4FCF2A-E707-DBE6-A82B-BD4EDBFD1188}"/>
+              </a:ext>
+            </a:extLst>
+          </p:cNvPr>
+          <p:cNvSpPr>
+            <a:spLocks noGrp="1"/>
+          </p:cNvSpPr>
+          <p:nvPr>
+            <p:ph idx="1"/>
+          </p:nvPr>
+        </p:nvSpPr>
+        <p:spPr/>
+        <p:txBody>
+          <a:bodyPr/>
+          <a:lstStyle/>
+          <a:p>
+            <a:r>
+              <a:rPr lang="en-GB" dirty="0"/>
+              <a:t>Multi-orbital Hubbard Model</a:t>
+            </a:r>
+          </a:p>
+        </p:txBody>
+      </p:sp>
+      <p:pic>
+        <p:nvPicPr>
+          <p:cNvPr id="10" name="Grafik 9">
+            <a:extLst>
+              <a:ext uri="{FF2B5EF4-FFF2-40B4-BE49-F238E27FC236}">
+                <a16:creationId xmlns:a16="http://schemas.microsoft.com/office/drawing/2014/main" id="{8097C8CA-66D8-D06F-4F43-62FEBBEBAD9C}"/>
+              </a:ext>
+            </a:extLst>
+          </p:cNvPr>
+          <p:cNvPicPr>
+            <a:picLocks noChangeAspect="1"/>
+          </p:cNvPicPr>
+          <p:nvPr/>
+        </p:nvPicPr>
+        <p:blipFill>
+          <a:blip r:embed="rId2"/>
+          <a:stretch>
+            <a:fillRect/>
+          </a:stretch>
+        </p:blipFill>
+        <p:spPr>
+          <a:xfrm>
+            <a:off x="1595437" y="3130941"/>
+            <a:ext cx="7558574" cy="2309907"/>
+          </a:xfrm>
+          <a:prstGeom prst="rect">
+            <a:avLst/>
+          </a:prstGeom>
+        </p:spPr>
+      </p:pic>
+      <p:pic>
+        <p:nvPicPr>
+          <p:cNvPr id="12" name="Grafik 11">
+            <a:extLst>
+              <a:ext uri="{FF2B5EF4-FFF2-40B4-BE49-F238E27FC236}">
+                <a16:creationId xmlns:a16="http://schemas.microsoft.com/office/drawing/2014/main" id="{BD0264B5-167D-B6B9-074F-27A4B3DCDE2F}"/>
+              </a:ext>
+            </a:extLst>
+          </p:cNvPr>
+          <p:cNvPicPr>
+            <a:picLocks noChangeAspect="1"/>
+          </p:cNvPicPr>
+          <p:nvPr/>
+        </p:nvPicPr>
+        <p:blipFill>
+          <a:blip r:embed="rId3"/>
+          <a:stretch>
+            <a:fillRect/>
+          </a:stretch>
+        </p:blipFill>
+        <p:spPr>
+          <a:xfrm>
+            <a:off x="7040478" y="445502"/>
+            <a:ext cx="4359951" cy="2309908"/>
+          </a:xfrm>
+          <a:prstGeom prst="rect">
+            <a:avLst/>
+          </a:prstGeom>
+        </p:spPr>
+      </p:pic>
+    </p:spTree>
+    <p:extLst>
+      <p:ext uri="{BB962C8B-B14F-4D97-AF65-F5344CB8AC3E}">
+        <p14:creationId xmlns:p14="http://schemas.microsoft.com/office/powerpoint/2010/main" val="2727654565"/>
+      </p:ext>
+    </p:extLst>
+  </p:cSld>
+  <p:clrMapOvr>
+    <a:masterClrMapping/>
+  </p:clrMapOvr>
+</p:sld>
+</file>
+
 <file path=ppt/tags/tag1.xml><?xml version="1.0" encoding="utf-8"?>
 <p:tagLst xmlns:a="http://schemas.openxmlformats.org/drawingml/2006/main" xmlns:r="http://schemas.openxmlformats.org/officeDocument/2006/relationships" xmlns:p="http://schemas.openxmlformats.org/presentationml/2006/main">
   <p:tag name="EE4P_STYLE_ID" val="6cd991bf-f022-4378-96e7-2c338aeb3f5a"/>
@@ -18178,6 +18479,12 @@
 </p:tagLst>
 </file>
 
+<file path=ppt/tags/tag1890.xml><?xml version="1.0" encoding="utf-8"?>
+<p:tagLst xmlns:a="http://schemas.openxmlformats.org/drawingml/2006/main" xmlns:r="http://schemas.openxmlformats.org/officeDocument/2006/relationships" xmlns:p="http://schemas.openxmlformats.org/presentationml/2006/main">
+  <p:tag name="SHAPE" val="OLD"/>
+</p:tagLst>
+</file>
+
 <file path=ppt/tags/tag19.xml><?xml version="1.0" encoding="utf-8"?>
 <p:tagLst xmlns:a="http://schemas.openxmlformats.org/drawingml/2006/main" xmlns:r="http://schemas.openxmlformats.org/officeDocument/2006/relationships" xmlns:p="http://schemas.openxmlformats.org/presentationml/2006/main">
   <p:tag name="SHAPE" val="OLD"/>
@@ -18268,61 +18575,7 @@
 </p:tagLst>
 </file>
 
-<file path=ppt/tags/tag202.xml><?xml version="1.0" encoding="utf-8"?>
-<p:tagLst xmlns:a="http://schemas.openxmlformats.org/drawingml/2006/main" xmlns:r="http://schemas.openxmlformats.org/officeDocument/2006/relationships" xmlns:p="http://schemas.openxmlformats.org/presentationml/2006/main">
-  <p:tag name="SHAPE" val="OLD"/>
-</p:tagLst>
-</file>
-
-<file path=ppt/tags/tag203.xml><?xml version="1.0" encoding="utf-8"?>
-<p:tagLst xmlns:a="http://schemas.openxmlformats.org/drawingml/2006/main" xmlns:r="http://schemas.openxmlformats.org/officeDocument/2006/relationships" xmlns:p="http://schemas.openxmlformats.org/presentationml/2006/main">
-  <p:tag name="SHAPE" val="OLD"/>
-</p:tagLst>
-</file>
-
-<file path=ppt/tags/tag204.xml><?xml version="1.0" encoding="utf-8"?>
-<p:tagLst xmlns:a="http://schemas.openxmlformats.org/drawingml/2006/main" xmlns:r="http://schemas.openxmlformats.org/officeDocument/2006/relationships" xmlns:p="http://schemas.openxmlformats.org/presentationml/2006/main">
-  <p:tag name="SHAPE" val="OLD"/>
-</p:tagLst>
-</file>
-
-<file path=ppt/tags/tag205.xml><?xml version="1.0" encoding="utf-8"?>
-<p:tagLst xmlns:a="http://schemas.openxmlformats.org/drawingml/2006/main" xmlns:r="http://schemas.openxmlformats.org/officeDocument/2006/relationships" xmlns:p="http://schemas.openxmlformats.org/presentationml/2006/main">
-  <p:tag name="SHAPE" val="OLD"/>
-</p:tagLst>
-</file>
-
-<file path=ppt/tags/tag206.xml><?xml version="1.0" encoding="utf-8"?>
-<p:tagLst xmlns:a="http://schemas.openxmlformats.org/drawingml/2006/main" xmlns:r="http://schemas.openxmlformats.org/officeDocument/2006/relationships" xmlns:p="http://schemas.openxmlformats.org/presentationml/2006/main">
-  <p:tag name="SHAPE" val="OLD"/>
-</p:tagLst>
-</file>
-
-<file path=ppt/tags/tag207.xml><?xml version="1.0" encoding="utf-8"?>
-<p:tagLst xmlns:a="http://schemas.openxmlformats.org/drawingml/2006/main" xmlns:r="http://schemas.openxmlformats.org/officeDocument/2006/relationships" xmlns:p="http://schemas.openxmlformats.org/presentationml/2006/main">
-  <p:tag name="SHAPE" val="OLD"/>
-</p:tagLst>
-</file>
-
-<file path=ppt/tags/tag208.xml><?xml version="1.0" encoding="utf-8"?>
-<p:tagLst xmlns:a="http://schemas.openxmlformats.org/drawingml/2006/main" xmlns:r="http://schemas.openxmlformats.org/officeDocument/2006/relationships" xmlns:p="http://schemas.openxmlformats.org/presentationml/2006/main">
-  <p:tag name="SHAPE" val="OLD"/>
-</p:tagLst>
-</file>
-
-<file path=ppt/tags/tag209.xml><?xml version="1.0" encoding="utf-8"?>
-<p:tagLst xmlns:a="http://schemas.openxmlformats.org/drawingml/2006/main" xmlns:r="http://schemas.openxmlformats.org/officeDocument/2006/relationships" xmlns:p="http://schemas.openxmlformats.org/presentationml/2006/main">
-  <p:tag name="SHAPE" val="OLD"/>
-</p:tagLst>
-</file>
-
 <file path=ppt/tags/tag21.xml><?xml version="1.0" encoding="utf-8"?>
-<p:tagLst xmlns:a="http://schemas.openxmlformats.org/drawingml/2006/main" xmlns:r="http://schemas.openxmlformats.org/officeDocument/2006/relationships" xmlns:p="http://schemas.openxmlformats.org/presentationml/2006/main">
-  <p:tag name="SHAPE" val="OLD"/>
-</p:tagLst>
-</file>
-
-<file path=ppt/tags/tag210.xml><?xml version="1.0" encoding="utf-8"?>
 <p:tagLst xmlns:a="http://schemas.openxmlformats.org/drawingml/2006/main" xmlns:r="http://schemas.openxmlformats.org/officeDocument/2006/relationships" xmlns:p="http://schemas.openxmlformats.org/presentationml/2006/main">
   <p:tag name="SHAPE" val="OLD"/>
 </p:tagLst>

</xml_diff>